<commit_message>
Slider- Creating image upload trait and handling image upload
</commit_message>
<xml_diff>
--- a/.lessons/54 Slider Features/3 Slider- Make create form dynamic/1.pptx
+++ b/.lessons/54 Slider Features/3 Slider- Make create form dynamic/1.pptx
@@ -7,7 +7,14 @@
   <p:sldIdLst>
     <p:sldId id="413" r:id="rId2"/>
     <p:sldId id="414" r:id="rId3"/>
-    <p:sldId id="400" r:id="rId4"/>
+    <p:sldId id="415" r:id="rId4"/>
+    <p:sldId id="418" r:id="rId5"/>
+    <p:sldId id="416" r:id="rId6"/>
+    <p:sldId id="417" r:id="rId7"/>
+    <p:sldId id="400" r:id="rId8"/>
+    <p:sldId id="420" r:id="rId9"/>
+    <p:sldId id="421" r:id="rId10"/>
+    <p:sldId id="422" r:id="rId11"/>
   </p:sldIdLst>
   <p:sldSz cx="12192000" cy="6858000"/>
   <p:notesSz cx="6858000" cy="9144000"/>
@@ -261,7 +268,7 @@
           <a:p>
             <a:fld id="{3E102D2E-813C-461C-9963-687A650C48C0}" type="datetimeFigureOut">
               <a:rPr lang="en-US" smtClean="0"/>
-              <a:t>6/26/2025</a:t>
+              <a:t>8/5/2025</a:t>
             </a:fld>
             <a:endParaRPr lang="en-US"/>
           </a:p>
@@ -459,7 +466,7 @@
           <a:p>
             <a:fld id="{3E102D2E-813C-461C-9963-687A650C48C0}" type="datetimeFigureOut">
               <a:rPr lang="en-US" smtClean="0"/>
-              <a:t>6/26/2025</a:t>
+              <a:t>8/5/2025</a:t>
             </a:fld>
             <a:endParaRPr lang="en-US"/>
           </a:p>
@@ -667,7 +674,7 @@
           <a:p>
             <a:fld id="{3E102D2E-813C-461C-9963-687A650C48C0}" type="datetimeFigureOut">
               <a:rPr lang="en-US" smtClean="0"/>
-              <a:t>6/26/2025</a:t>
+              <a:t>8/5/2025</a:t>
             </a:fld>
             <a:endParaRPr lang="en-US"/>
           </a:p>
@@ -865,7 +872,7 @@
           <a:p>
             <a:fld id="{3E102D2E-813C-461C-9963-687A650C48C0}" type="datetimeFigureOut">
               <a:rPr lang="en-US" smtClean="0"/>
-              <a:t>6/26/2025</a:t>
+              <a:t>8/5/2025</a:t>
             </a:fld>
             <a:endParaRPr lang="en-US"/>
           </a:p>
@@ -1140,7 +1147,7 @@
           <a:p>
             <a:fld id="{3E102D2E-813C-461C-9963-687A650C48C0}" type="datetimeFigureOut">
               <a:rPr lang="en-US" smtClean="0"/>
-              <a:t>6/26/2025</a:t>
+              <a:t>8/5/2025</a:t>
             </a:fld>
             <a:endParaRPr lang="en-US"/>
           </a:p>
@@ -1405,7 +1412,7 @@
           <a:p>
             <a:fld id="{3E102D2E-813C-461C-9963-687A650C48C0}" type="datetimeFigureOut">
               <a:rPr lang="en-US" smtClean="0"/>
-              <a:t>6/26/2025</a:t>
+              <a:t>8/5/2025</a:t>
             </a:fld>
             <a:endParaRPr lang="en-US"/>
           </a:p>
@@ -1817,7 +1824,7 @@
           <a:p>
             <a:fld id="{3E102D2E-813C-461C-9963-687A650C48C0}" type="datetimeFigureOut">
               <a:rPr lang="en-US" smtClean="0"/>
-              <a:t>6/26/2025</a:t>
+              <a:t>8/5/2025</a:t>
             </a:fld>
             <a:endParaRPr lang="en-US"/>
           </a:p>
@@ -1958,7 +1965,7 @@
           <a:p>
             <a:fld id="{3E102D2E-813C-461C-9963-687A650C48C0}" type="datetimeFigureOut">
               <a:rPr lang="en-US" smtClean="0"/>
-              <a:t>6/26/2025</a:t>
+              <a:t>8/5/2025</a:t>
             </a:fld>
             <a:endParaRPr lang="en-US"/>
           </a:p>
@@ -2071,7 +2078,7 @@
           <a:p>
             <a:fld id="{3E102D2E-813C-461C-9963-687A650C48C0}" type="datetimeFigureOut">
               <a:rPr lang="en-US" smtClean="0"/>
-              <a:t>6/26/2025</a:t>
+              <a:t>8/5/2025</a:t>
             </a:fld>
             <a:endParaRPr lang="en-US"/>
           </a:p>
@@ -2382,7 +2389,7 @@
           <a:p>
             <a:fld id="{3E102D2E-813C-461C-9963-687A650C48C0}" type="datetimeFigureOut">
               <a:rPr lang="en-US" smtClean="0"/>
-              <a:t>6/26/2025</a:t>
+              <a:t>8/5/2025</a:t>
             </a:fld>
             <a:endParaRPr lang="en-US"/>
           </a:p>
@@ -2670,7 +2677,7 @@
           <a:p>
             <a:fld id="{3E102D2E-813C-461C-9963-687A650C48C0}" type="datetimeFigureOut">
               <a:rPr lang="en-US" smtClean="0"/>
-              <a:t>6/26/2025</a:t>
+              <a:t>8/5/2025</a:t>
             </a:fld>
             <a:endParaRPr lang="en-US"/>
           </a:p>
@@ -2911,7 +2918,7 @@
           <a:p>
             <a:fld id="{3E102D2E-813C-461C-9963-687A650C48C0}" type="datetimeFigureOut">
               <a:rPr lang="en-US" smtClean="0"/>
-              <a:t>6/26/2025</a:t>
+              <a:t>8/5/2025</a:t>
             </a:fld>
             <a:endParaRPr lang="en-US"/>
           </a:p>
@@ -3348,6 +3355,150 @@
         </p:nvSpPr>
         <p:spPr>
           <a:xfrm>
+            <a:off x="217714" y="255047"/>
+            <a:ext cx="11756571" cy="355354"/>
+          </a:xfrm>
+          <a:prstGeom prst="rect">
+            <a:avLst/>
+          </a:prstGeom>
+          <a:noFill/>
+        </p:spPr>
+        <p:txBody>
+          <a:bodyPr wrap="square">
+            <a:spAutoFit/>
+          </a:bodyPr>
+          <a:lstStyle/>
+          <a:p>
+            <a:pPr>
+              <a:lnSpc>
+                <a:spcPct val="150000"/>
+              </a:lnSpc>
+              <a:buNone/>
+            </a:pPr>
+            <a:r>
+              <a:rPr kumimoji="0" lang="az-Latn-AZ" altLang="en-US" sz="1300" b="0" i="0" u="none" strike="noStrike" cap="none" normalizeH="0" baseline="0">
+                <a:ln>
+                  <a:noFill/>
+                </a:ln>
+                <a:solidFill>
+                  <a:schemeClr val="tx1"/>
+                </a:solidFill>
+                <a:effectLst/>
+                <a:latin typeface="Arial" panose="020B0604020202020204" pitchFamily="34" charset="0"/>
+              </a:rPr>
+              <a:t>Slider cədvələni</a:t>
+            </a:r>
+            <a:r>
+              <a:rPr lang="az-Latn-AZ" altLang="en-US" sz="1300">
+                <a:latin typeface="Arial" panose="020B0604020202020204" pitchFamily="34" charset="0"/>
+              </a:rPr>
+              <a:t>n sütunlarını yaradırıq və </a:t>
+            </a:r>
+            <a:r>
+              <a:rPr lang="az-Latn-AZ" altLang="en-US" sz="1300" b="1">
+                <a:latin typeface="Arial" panose="020B0604020202020204" pitchFamily="34" charset="0"/>
+              </a:rPr>
+              <a:t>migrate</a:t>
+            </a:r>
+            <a:r>
+              <a:rPr lang="az-Latn-AZ" altLang="en-US" sz="1300">
+                <a:latin typeface="Arial" panose="020B0604020202020204" pitchFamily="34" charset="0"/>
+              </a:rPr>
+              <a:t> edirik.</a:t>
+            </a:r>
+            <a:endParaRPr kumimoji="0" lang="en-US" altLang="en-US" sz="1300" b="0" i="0" u="none" strike="noStrike" cap="none" normalizeH="0" baseline="0">
+              <a:ln>
+                <a:noFill/>
+              </a:ln>
+              <a:solidFill>
+                <a:schemeClr val="tx1"/>
+              </a:solidFill>
+              <a:effectLst/>
+              <a:latin typeface="Arial" panose="020B0604020202020204" pitchFamily="34" charset="0"/>
+            </a:endParaRPr>
+          </a:p>
+        </p:txBody>
+      </p:sp>
+      <p:pic>
+        <p:nvPicPr>
+          <p:cNvPr id="4" name="Picture 3">
+            <a:extLst>
+              <a:ext uri="{FF2B5EF4-FFF2-40B4-BE49-F238E27FC236}">
+                <a16:creationId xmlns:a16="http://schemas.microsoft.com/office/drawing/2014/main" id="{492254B7-28DC-AB35-1C70-CAEF3AD6CCF7}"/>
+              </a:ext>
+            </a:extLst>
+          </p:cNvPr>
+          <p:cNvPicPr>
+            <a:picLocks noChangeAspect="1"/>
+          </p:cNvPicPr>
+          <p:nvPr/>
+        </p:nvPicPr>
+        <p:blipFill>
+          <a:blip r:embed="rId2"/>
+          <a:stretch>
+            <a:fillRect/>
+          </a:stretch>
+        </p:blipFill>
+        <p:spPr>
+          <a:xfrm>
+            <a:off x="3703782" y="789568"/>
+            <a:ext cx="8488218" cy="6068431"/>
+          </a:xfrm>
+          <a:prstGeom prst="rect">
+            <a:avLst/>
+          </a:prstGeom>
+        </p:spPr>
+      </p:pic>
+    </p:spTree>
+    <p:extLst>
+      <p:ext uri="{BB962C8B-B14F-4D97-AF65-F5344CB8AC3E}">
+        <p14:creationId xmlns:p14="http://schemas.microsoft.com/office/powerpoint/2010/main" val="3863838039"/>
+      </p:ext>
+    </p:extLst>
+  </p:cSld>
+  <p:clrMapOvr>
+    <a:masterClrMapping/>
+  </p:clrMapOvr>
+</p:sld>
+</file>
+
+<file path=ppt/slides/slide10.xml><?xml version="1.0" encoding="utf-8"?>
+<p:sld xmlns:a="http://schemas.openxmlformats.org/drawingml/2006/main" xmlns:r="http://schemas.openxmlformats.org/officeDocument/2006/relationships" xmlns:p="http://schemas.openxmlformats.org/presentationml/2006/main">
+  <p:cSld>
+    <p:spTree>
+      <p:nvGrpSpPr>
+        <p:cNvPr id="1" name="">
+          <a:extLst>
+            <a:ext uri="{FF2B5EF4-FFF2-40B4-BE49-F238E27FC236}">
+              <a16:creationId xmlns:a16="http://schemas.microsoft.com/office/drawing/2014/main" id="{80DF31AE-E6BD-961F-F80C-08CE6B500353}"/>
+            </a:ext>
+          </a:extLst>
+        </p:cNvPr>
+        <p:cNvGrpSpPr/>
+        <p:nvPr/>
+      </p:nvGrpSpPr>
+      <p:grpSpPr>
+        <a:xfrm>
+          <a:off x="0" y="0"/>
+          <a:ext cx="0" cy="0"/>
+          <a:chOff x="0" y="0"/>
+          <a:chExt cx="0" cy="0"/>
+        </a:xfrm>
+      </p:grpSpPr>
+      <p:sp>
+        <p:nvSpPr>
+          <p:cNvPr id="3" name="TextBox 2">
+            <a:extLst>
+              <a:ext uri="{FF2B5EF4-FFF2-40B4-BE49-F238E27FC236}">
+                <a16:creationId xmlns:a16="http://schemas.microsoft.com/office/drawing/2014/main" id="{396073F4-12FA-7C32-4B57-DE57B2F5C985}"/>
+              </a:ext>
+            </a:extLst>
+          </p:cNvPr>
+          <p:cNvSpPr txBox="1"/>
+          <p:nvPr/>
+        </p:nvSpPr>
+        <p:spPr>
+          <a:xfrm>
             <a:off x="217714" y="255046"/>
             <a:ext cx="11756571" cy="355354"/>
           </a:xfrm>
@@ -3387,7 +3538,7 @@
     </p:spTree>
     <p:extLst>
       <p:ext uri="{BB962C8B-B14F-4D97-AF65-F5344CB8AC3E}">
-        <p14:creationId xmlns:p14="http://schemas.microsoft.com/office/powerpoint/2010/main" val="3863838039"/>
+        <p14:creationId xmlns:p14="http://schemas.microsoft.com/office/powerpoint/2010/main" val="324069914"/>
       </p:ext>
     </p:extLst>
   </p:cSld>
@@ -3470,6 +3621,36 @@
           </a:p>
         </p:txBody>
       </p:sp>
+      <p:pic>
+        <p:nvPicPr>
+          <p:cNvPr id="4" name="Picture 3">
+            <a:extLst>
+              <a:ext uri="{FF2B5EF4-FFF2-40B4-BE49-F238E27FC236}">
+                <a16:creationId xmlns:a16="http://schemas.microsoft.com/office/drawing/2014/main" id="{111690E6-B5CB-D2E1-E2E1-63495E28B004}"/>
+              </a:ext>
+            </a:extLst>
+          </p:cNvPr>
+          <p:cNvPicPr>
+            <a:picLocks noChangeAspect="1"/>
+          </p:cNvPicPr>
+          <p:nvPr/>
+        </p:nvPicPr>
+        <p:blipFill>
+          <a:blip r:embed="rId2"/>
+          <a:stretch>
+            <a:fillRect/>
+          </a:stretch>
+        </p:blipFill>
+        <p:spPr>
+          <a:xfrm>
+            <a:off x="3170243" y="0"/>
+            <a:ext cx="5851513" cy="6858000"/>
+          </a:xfrm>
+          <a:prstGeom prst="rect">
+            <a:avLst/>
+          </a:prstGeom>
+        </p:spPr>
+      </p:pic>
     </p:spTree>
     <p:extLst>
       <p:ext uri="{BB962C8B-B14F-4D97-AF65-F5344CB8AC3E}">
@@ -3484,6 +3665,806 @@
 </file>
 
 <file path=ppt/slides/slide3.xml><?xml version="1.0" encoding="utf-8"?>
+<p:sld xmlns:a="http://schemas.openxmlformats.org/drawingml/2006/main" xmlns:r="http://schemas.openxmlformats.org/officeDocument/2006/relationships" xmlns:p="http://schemas.openxmlformats.org/presentationml/2006/main">
+  <p:cSld>
+    <p:spTree>
+      <p:nvGrpSpPr>
+        <p:cNvPr id="1" name="">
+          <a:extLst>
+            <a:ext uri="{FF2B5EF4-FFF2-40B4-BE49-F238E27FC236}">
+              <a16:creationId xmlns:a16="http://schemas.microsoft.com/office/drawing/2014/main" id="{2E887149-16FD-79DD-9A1E-BBC4FC30D160}"/>
+            </a:ext>
+          </a:extLst>
+        </p:cNvPr>
+        <p:cNvGrpSpPr/>
+        <p:nvPr/>
+      </p:nvGrpSpPr>
+      <p:grpSpPr>
+        <a:xfrm>
+          <a:off x="0" y="0"/>
+          <a:ext cx="0" cy="0"/>
+          <a:chOff x="0" y="0"/>
+          <a:chExt cx="0" cy="0"/>
+        </a:xfrm>
+      </p:grpSpPr>
+      <p:sp>
+        <p:nvSpPr>
+          <p:cNvPr id="3" name="TextBox 2">
+            <a:extLst>
+              <a:ext uri="{FF2B5EF4-FFF2-40B4-BE49-F238E27FC236}">
+                <a16:creationId xmlns:a16="http://schemas.microsoft.com/office/drawing/2014/main" id="{EF2A5673-D6C3-8E1C-C77D-5752E1412CEA}"/>
+              </a:ext>
+            </a:extLst>
+          </p:cNvPr>
+          <p:cNvSpPr txBox="1"/>
+          <p:nvPr/>
+        </p:nvSpPr>
+        <p:spPr>
+          <a:xfrm>
+            <a:off x="217713" y="83127"/>
+            <a:ext cx="11756571" cy="355354"/>
+          </a:xfrm>
+          <a:prstGeom prst="rect">
+            <a:avLst/>
+          </a:prstGeom>
+          <a:noFill/>
+        </p:spPr>
+        <p:txBody>
+          <a:bodyPr wrap="square">
+            <a:spAutoFit/>
+          </a:bodyPr>
+          <a:lstStyle/>
+          <a:p>
+            <a:pPr>
+              <a:lnSpc>
+                <a:spcPct val="150000"/>
+              </a:lnSpc>
+              <a:buNone/>
+            </a:pPr>
+            <a:r>
+              <a:rPr kumimoji="0" lang="az-Latn-AZ" altLang="en-US" sz="1300" b="0" i="0" u="none" strike="noStrike" cap="none" normalizeH="0" baseline="0">
+                <a:ln>
+                  <a:noFill/>
+                </a:ln>
+                <a:solidFill>
+                  <a:schemeClr val="tx1"/>
+                </a:solidFill>
+                <a:effectLst/>
+                <a:latin typeface="Arial" panose="020B0604020202020204" pitchFamily="34" charset="0"/>
+              </a:rPr>
+              <a:t>Su</a:t>
+            </a:r>
+            <a:r>
+              <a:rPr lang="az-Latn-AZ" altLang="en-US" sz="1300">
+                <a:latin typeface="Arial" panose="020B0604020202020204" pitchFamily="34" charset="0"/>
+              </a:rPr>
+              <a:t>bmit üçün route əlavə edirik.</a:t>
+            </a:r>
+            <a:endParaRPr kumimoji="0" lang="en-US" altLang="en-US" sz="1300" b="0" i="0" u="none" strike="noStrike" cap="none" normalizeH="0" baseline="0">
+              <a:ln>
+                <a:noFill/>
+              </a:ln>
+              <a:solidFill>
+                <a:schemeClr val="tx1"/>
+              </a:solidFill>
+              <a:effectLst/>
+              <a:latin typeface="Arial" panose="020B0604020202020204" pitchFamily="34" charset="0"/>
+            </a:endParaRPr>
+          </a:p>
+        </p:txBody>
+      </p:sp>
+      <p:pic>
+        <p:nvPicPr>
+          <p:cNvPr id="4" name="Picture 3">
+            <a:extLst>
+              <a:ext uri="{FF2B5EF4-FFF2-40B4-BE49-F238E27FC236}">
+                <a16:creationId xmlns:a16="http://schemas.microsoft.com/office/drawing/2014/main" id="{0A37EF35-6E8A-4921-72A4-7EB2F17C595D}"/>
+              </a:ext>
+            </a:extLst>
+          </p:cNvPr>
+          <p:cNvPicPr>
+            <a:picLocks noChangeAspect="1"/>
+          </p:cNvPicPr>
+          <p:nvPr/>
+        </p:nvPicPr>
+        <p:blipFill>
+          <a:blip r:embed="rId2"/>
+          <a:stretch>
+            <a:fillRect/>
+          </a:stretch>
+        </p:blipFill>
+        <p:spPr>
+          <a:xfrm>
+            <a:off x="-1" y="508000"/>
+            <a:ext cx="12192000" cy="6350000"/>
+          </a:xfrm>
+          <a:prstGeom prst="rect">
+            <a:avLst/>
+          </a:prstGeom>
+        </p:spPr>
+      </p:pic>
+    </p:spTree>
+    <p:extLst>
+      <p:ext uri="{BB962C8B-B14F-4D97-AF65-F5344CB8AC3E}">
+        <p14:creationId xmlns:p14="http://schemas.microsoft.com/office/powerpoint/2010/main" val="150732045"/>
+      </p:ext>
+    </p:extLst>
+  </p:cSld>
+  <p:clrMapOvr>
+    <a:masterClrMapping/>
+  </p:clrMapOvr>
+</p:sld>
+</file>
+
+<file path=ppt/slides/slide4.xml><?xml version="1.0" encoding="utf-8"?>
+<p:sld xmlns:a="http://schemas.openxmlformats.org/drawingml/2006/main" xmlns:r="http://schemas.openxmlformats.org/officeDocument/2006/relationships" xmlns:p="http://schemas.openxmlformats.org/presentationml/2006/main">
+  <p:cSld>
+    <p:spTree>
+      <p:nvGrpSpPr>
+        <p:cNvPr id="1" name="">
+          <a:extLst>
+            <a:ext uri="{FF2B5EF4-FFF2-40B4-BE49-F238E27FC236}">
+              <a16:creationId xmlns:a16="http://schemas.microsoft.com/office/drawing/2014/main" id="{13AC8E67-BA78-AC7E-FF8E-B72024ACB397}"/>
+            </a:ext>
+          </a:extLst>
+        </p:cNvPr>
+        <p:cNvGrpSpPr/>
+        <p:nvPr/>
+      </p:nvGrpSpPr>
+      <p:grpSpPr>
+        <a:xfrm>
+          <a:off x="0" y="0"/>
+          <a:ext cx="0" cy="0"/>
+          <a:chOff x="0" y="0"/>
+          <a:chExt cx="0" cy="0"/>
+        </a:xfrm>
+      </p:grpSpPr>
+      <p:sp>
+        <p:nvSpPr>
+          <p:cNvPr id="3" name="TextBox 2">
+            <a:extLst>
+              <a:ext uri="{FF2B5EF4-FFF2-40B4-BE49-F238E27FC236}">
+                <a16:creationId xmlns:a16="http://schemas.microsoft.com/office/drawing/2014/main" id="{F28C3A28-E272-C771-4869-83EEDD75834A}"/>
+              </a:ext>
+            </a:extLst>
+          </p:cNvPr>
+          <p:cNvSpPr txBox="1"/>
+          <p:nvPr/>
+        </p:nvSpPr>
+        <p:spPr>
+          <a:xfrm>
+            <a:off x="217714" y="255046"/>
+            <a:ext cx="11756571" cy="355354"/>
+          </a:xfrm>
+          <a:prstGeom prst="rect">
+            <a:avLst/>
+          </a:prstGeom>
+          <a:noFill/>
+        </p:spPr>
+        <p:txBody>
+          <a:bodyPr wrap="square">
+            <a:spAutoFit/>
+          </a:bodyPr>
+          <a:lstStyle/>
+          <a:p>
+            <a:pPr>
+              <a:lnSpc>
+                <a:spcPct val="150000"/>
+              </a:lnSpc>
+              <a:buNone/>
+            </a:pPr>
+            <a:r>
+              <a:rPr lang="en-US" altLang="en-US" sz="1300">
+                <a:latin typeface="Arial" panose="020B0604020202020204" pitchFamily="34" charset="0"/>
+              </a:rPr>
+              <a:t>`</a:t>
+            </a:r>
+            <a:r>
+              <a:rPr lang="en-US" altLang="en-US" sz="1300" b="1">
+                <a:latin typeface="Arial" panose="020B0604020202020204" pitchFamily="34" charset="0"/>
+              </a:rPr>
+              <a:t>app\Http\Controllers\Backend\</a:t>
+            </a:r>
+            <a:r>
+              <a:rPr lang="en-US" altLang="en-US" sz="1300" b="1" u="sng">
+                <a:latin typeface="Arial" panose="020B0604020202020204" pitchFamily="34" charset="0"/>
+              </a:rPr>
+              <a:t>SliderController.php</a:t>
+            </a:r>
+            <a:r>
+              <a:rPr lang="en-US" altLang="en-US" sz="1300">
+                <a:latin typeface="Arial" panose="020B0604020202020204" pitchFamily="34" charset="0"/>
+              </a:rPr>
+              <a:t>` </a:t>
+            </a:r>
+            <a:r>
+              <a:rPr lang="az-Latn-AZ" altLang="en-US" sz="1300">
+                <a:latin typeface="Arial" panose="020B0604020202020204" pitchFamily="34" charset="0"/>
+              </a:rPr>
+              <a:t>yazırıq.</a:t>
+            </a:r>
+            <a:endParaRPr kumimoji="0" lang="en-US" altLang="en-US" sz="1300" b="0" i="0" u="none" strike="noStrike" cap="none" normalizeH="0" baseline="0">
+              <a:ln>
+                <a:noFill/>
+              </a:ln>
+              <a:solidFill>
+                <a:schemeClr val="tx1"/>
+              </a:solidFill>
+              <a:effectLst/>
+              <a:latin typeface="Arial" panose="020B0604020202020204" pitchFamily="34" charset="0"/>
+            </a:endParaRPr>
+          </a:p>
+        </p:txBody>
+      </p:sp>
+      <p:pic>
+        <p:nvPicPr>
+          <p:cNvPr id="6" name="Picture 5">
+            <a:extLst>
+              <a:ext uri="{FF2B5EF4-FFF2-40B4-BE49-F238E27FC236}">
+                <a16:creationId xmlns:a16="http://schemas.microsoft.com/office/drawing/2014/main" id="{3C27C294-1648-9B58-65C8-7538B39C5F98}"/>
+              </a:ext>
+            </a:extLst>
+          </p:cNvPr>
+          <p:cNvPicPr>
+            <a:picLocks noChangeAspect="1"/>
+          </p:cNvPicPr>
+          <p:nvPr/>
+        </p:nvPicPr>
+        <p:blipFill>
+          <a:blip r:embed="rId2"/>
+          <a:stretch>
+            <a:fillRect/>
+          </a:stretch>
+        </p:blipFill>
+        <p:spPr>
+          <a:xfrm>
+            <a:off x="8178591" y="0"/>
+            <a:ext cx="4013409" cy="6858000"/>
+          </a:xfrm>
+          <a:prstGeom prst="rect">
+            <a:avLst/>
+          </a:prstGeom>
+        </p:spPr>
+      </p:pic>
+    </p:spTree>
+    <p:extLst>
+      <p:ext uri="{BB962C8B-B14F-4D97-AF65-F5344CB8AC3E}">
+        <p14:creationId xmlns:p14="http://schemas.microsoft.com/office/powerpoint/2010/main" val="1081428709"/>
+      </p:ext>
+    </p:extLst>
+  </p:cSld>
+  <p:clrMapOvr>
+    <a:masterClrMapping/>
+  </p:clrMapOvr>
+</p:sld>
+</file>
+
+<file path=ppt/slides/slide5.xml><?xml version="1.0" encoding="utf-8"?>
+<p:sld xmlns:a="http://schemas.openxmlformats.org/drawingml/2006/main" xmlns:r="http://schemas.openxmlformats.org/officeDocument/2006/relationships" xmlns:p="http://schemas.openxmlformats.org/presentationml/2006/main">
+  <p:cSld>
+    <p:spTree>
+      <p:nvGrpSpPr>
+        <p:cNvPr id="1" name="">
+          <a:extLst>
+            <a:ext uri="{FF2B5EF4-FFF2-40B4-BE49-F238E27FC236}">
+              <a16:creationId xmlns:a16="http://schemas.microsoft.com/office/drawing/2014/main" id="{140D3AF3-80EE-4F95-90A5-186410055567}"/>
+            </a:ext>
+          </a:extLst>
+        </p:cNvPr>
+        <p:cNvGrpSpPr/>
+        <p:nvPr/>
+      </p:nvGrpSpPr>
+      <p:grpSpPr>
+        <a:xfrm>
+          <a:off x="0" y="0"/>
+          <a:ext cx="0" cy="0"/>
+          <a:chOff x="0" y="0"/>
+          <a:chExt cx="0" cy="0"/>
+        </a:xfrm>
+      </p:grpSpPr>
+      <p:sp>
+        <p:nvSpPr>
+          <p:cNvPr id="3" name="TextBox 2">
+            <a:extLst>
+              <a:ext uri="{FF2B5EF4-FFF2-40B4-BE49-F238E27FC236}">
+                <a16:creationId xmlns:a16="http://schemas.microsoft.com/office/drawing/2014/main" id="{263CECCC-6BA5-37E0-5BC6-4DE2F983917A}"/>
+              </a:ext>
+            </a:extLst>
+          </p:cNvPr>
+          <p:cNvSpPr txBox="1"/>
+          <p:nvPr/>
+        </p:nvSpPr>
+        <p:spPr>
+          <a:xfrm>
+            <a:off x="217714" y="118687"/>
+            <a:ext cx="11756571" cy="355354"/>
+          </a:xfrm>
+          <a:prstGeom prst="rect">
+            <a:avLst/>
+          </a:prstGeom>
+          <a:noFill/>
+        </p:spPr>
+        <p:txBody>
+          <a:bodyPr wrap="square">
+            <a:spAutoFit/>
+          </a:bodyPr>
+          <a:lstStyle/>
+          <a:p>
+            <a:pPr>
+              <a:lnSpc>
+                <a:spcPct val="150000"/>
+              </a:lnSpc>
+              <a:buNone/>
+            </a:pPr>
+            <a:r>
+              <a:rPr lang="az-Latn-AZ" altLang="en-US" sz="1300">
+                <a:latin typeface="Arial" panose="020B0604020202020204" pitchFamily="34" charset="0"/>
+              </a:rPr>
+              <a:t>Sahələri doldururuq və </a:t>
+            </a:r>
+            <a:r>
+              <a:rPr lang="az-Latn-AZ" altLang="en-US" sz="1300" b="1">
+                <a:latin typeface="Arial" panose="020B0604020202020204" pitchFamily="34" charset="0"/>
+              </a:rPr>
+              <a:t>Create</a:t>
+            </a:r>
+            <a:r>
+              <a:rPr lang="az-Latn-AZ" altLang="en-US" sz="1300">
+                <a:latin typeface="Arial" panose="020B0604020202020204" pitchFamily="34" charset="0"/>
+              </a:rPr>
+              <a:t> düyməsini klikləyirik.</a:t>
+            </a:r>
+            <a:endParaRPr kumimoji="0" lang="en-US" altLang="en-US" sz="1300" b="0" i="0" u="none" strike="noStrike" cap="none" normalizeH="0" baseline="0">
+              <a:ln>
+                <a:noFill/>
+              </a:ln>
+              <a:solidFill>
+                <a:schemeClr val="tx1"/>
+              </a:solidFill>
+              <a:effectLst/>
+              <a:latin typeface="Arial" panose="020B0604020202020204" pitchFamily="34" charset="0"/>
+            </a:endParaRPr>
+          </a:p>
+        </p:txBody>
+      </p:sp>
+      <p:pic>
+        <p:nvPicPr>
+          <p:cNvPr id="4" name="Picture 3">
+            <a:extLst>
+              <a:ext uri="{FF2B5EF4-FFF2-40B4-BE49-F238E27FC236}">
+                <a16:creationId xmlns:a16="http://schemas.microsoft.com/office/drawing/2014/main" id="{289F5F83-FA79-50B8-EDC6-61C5BF8BF825}"/>
+              </a:ext>
+            </a:extLst>
+          </p:cNvPr>
+          <p:cNvPicPr>
+            <a:picLocks noChangeAspect="1"/>
+          </p:cNvPicPr>
+          <p:nvPr/>
+        </p:nvPicPr>
+        <p:blipFill>
+          <a:blip r:embed="rId2"/>
+          <a:stretch>
+            <a:fillRect/>
+          </a:stretch>
+        </p:blipFill>
+        <p:spPr>
+          <a:xfrm>
+            <a:off x="0" y="625404"/>
+            <a:ext cx="12192000" cy="6232596"/>
+          </a:xfrm>
+          <a:prstGeom prst="rect">
+            <a:avLst/>
+          </a:prstGeom>
+        </p:spPr>
+      </p:pic>
+    </p:spTree>
+    <p:extLst>
+      <p:ext uri="{BB962C8B-B14F-4D97-AF65-F5344CB8AC3E}">
+        <p14:creationId xmlns:p14="http://schemas.microsoft.com/office/powerpoint/2010/main" val="3125824508"/>
+      </p:ext>
+    </p:extLst>
+  </p:cSld>
+  <p:clrMapOvr>
+    <a:masterClrMapping/>
+  </p:clrMapOvr>
+</p:sld>
+</file>
+
+<file path=ppt/slides/slide6.xml><?xml version="1.0" encoding="utf-8"?>
+<p:sld xmlns:a="http://schemas.openxmlformats.org/drawingml/2006/main" xmlns:r="http://schemas.openxmlformats.org/officeDocument/2006/relationships" xmlns:p="http://schemas.openxmlformats.org/presentationml/2006/main">
+  <p:cSld>
+    <p:spTree>
+      <p:nvGrpSpPr>
+        <p:cNvPr id="1" name="">
+          <a:extLst>
+            <a:ext uri="{FF2B5EF4-FFF2-40B4-BE49-F238E27FC236}">
+              <a16:creationId xmlns:a16="http://schemas.microsoft.com/office/drawing/2014/main" id="{082E6DA9-4B4E-02B2-AB0B-3F36F0C52073}"/>
+            </a:ext>
+          </a:extLst>
+        </p:cNvPr>
+        <p:cNvGrpSpPr/>
+        <p:nvPr/>
+      </p:nvGrpSpPr>
+      <p:grpSpPr>
+        <a:xfrm>
+          <a:off x="0" y="0"/>
+          <a:ext cx="0" cy="0"/>
+          <a:chOff x="0" y="0"/>
+          <a:chExt cx="0" cy="0"/>
+        </a:xfrm>
+      </p:grpSpPr>
+      <p:sp>
+        <p:nvSpPr>
+          <p:cNvPr id="3" name="TextBox 2">
+            <a:extLst>
+              <a:ext uri="{FF2B5EF4-FFF2-40B4-BE49-F238E27FC236}">
+                <a16:creationId xmlns:a16="http://schemas.microsoft.com/office/drawing/2014/main" id="{278392A1-51B4-FE47-6CD7-E0919905607A}"/>
+              </a:ext>
+            </a:extLst>
+          </p:cNvPr>
+          <p:cNvSpPr txBox="1"/>
+          <p:nvPr/>
+        </p:nvSpPr>
+        <p:spPr>
+          <a:xfrm>
+            <a:off x="217713" y="42622"/>
+            <a:ext cx="11756571" cy="3656257"/>
+          </a:xfrm>
+          <a:prstGeom prst="rect">
+            <a:avLst/>
+          </a:prstGeom>
+          <a:noFill/>
+        </p:spPr>
+        <p:txBody>
+          <a:bodyPr wrap="square">
+            <a:spAutoFit/>
+          </a:bodyPr>
+          <a:lstStyle/>
+          <a:p>
+            <a:pPr>
+              <a:lnSpc>
+                <a:spcPct val="150000"/>
+              </a:lnSpc>
+              <a:buNone/>
+            </a:pPr>
+            <a:r>
+              <a:rPr lang="az-Latn-AZ" altLang="en-US" sz="1300">
+                <a:latin typeface="Arial" panose="020B0604020202020204" pitchFamily="34" charset="0"/>
+              </a:rPr>
+              <a:t>Məlumatlar uğurla </a:t>
+            </a:r>
+            <a:r>
+              <a:rPr lang="az-Latn-AZ" altLang="en-US" sz="1300" b="1">
+                <a:latin typeface="Arial" panose="020B0604020202020204" pitchFamily="34" charset="0"/>
+              </a:rPr>
+              <a:t>DB</a:t>
+            </a:r>
+            <a:r>
+              <a:rPr lang="az-Latn-AZ" altLang="en-US" sz="1300">
+                <a:latin typeface="Arial" panose="020B0604020202020204" pitchFamily="34" charset="0"/>
+              </a:rPr>
+              <a:t> -zə göndərildi.</a:t>
+            </a:r>
+          </a:p>
+          <a:p>
+            <a:pPr>
+              <a:lnSpc>
+                <a:spcPct val="150000"/>
+              </a:lnSpc>
+              <a:buNone/>
+            </a:pPr>
+            <a:endParaRPr kumimoji="0" lang="az-Latn-AZ" altLang="en-US" sz="1300" b="0" i="0" u="none" strike="noStrike" cap="none" normalizeH="0" baseline="0">
+              <a:ln>
+                <a:noFill/>
+              </a:ln>
+              <a:solidFill>
+                <a:schemeClr val="tx1"/>
+              </a:solidFill>
+              <a:effectLst/>
+              <a:latin typeface="Arial" panose="020B0604020202020204" pitchFamily="34" charset="0"/>
+            </a:endParaRPr>
+          </a:p>
+          <a:p>
+            <a:pPr>
+              <a:lnSpc>
+                <a:spcPct val="150000"/>
+              </a:lnSpc>
+              <a:buNone/>
+            </a:pPr>
+            <a:endParaRPr lang="az-Latn-AZ" altLang="en-US" sz="1300">
+              <a:latin typeface="Arial" panose="020B0604020202020204" pitchFamily="34" charset="0"/>
+            </a:endParaRPr>
+          </a:p>
+          <a:p>
+            <a:pPr>
+              <a:lnSpc>
+                <a:spcPct val="150000"/>
+              </a:lnSpc>
+              <a:buNone/>
+            </a:pPr>
+            <a:endParaRPr kumimoji="0" lang="az-Latn-AZ" altLang="en-US" sz="1300" b="0" i="0" u="none" strike="noStrike" cap="none" normalizeH="0" baseline="0">
+              <a:ln>
+                <a:noFill/>
+              </a:ln>
+              <a:solidFill>
+                <a:schemeClr val="tx1"/>
+              </a:solidFill>
+              <a:effectLst/>
+              <a:latin typeface="Arial" panose="020B0604020202020204" pitchFamily="34" charset="0"/>
+            </a:endParaRPr>
+          </a:p>
+          <a:p>
+            <a:pPr>
+              <a:lnSpc>
+                <a:spcPct val="150000"/>
+              </a:lnSpc>
+              <a:buNone/>
+            </a:pPr>
+            <a:endParaRPr lang="az-Latn-AZ" altLang="en-US" sz="1300">
+              <a:latin typeface="Arial" panose="020B0604020202020204" pitchFamily="34" charset="0"/>
+            </a:endParaRPr>
+          </a:p>
+          <a:p>
+            <a:pPr>
+              <a:lnSpc>
+                <a:spcPct val="150000"/>
+              </a:lnSpc>
+              <a:buNone/>
+            </a:pPr>
+            <a:endParaRPr kumimoji="0" lang="az-Latn-AZ" altLang="en-US" sz="1300" b="0" i="0" u="none" strike="noStrike" cap="none" normalizeH="0" baseline="0">
+              <a:ln>
+                <a:noFill/>
+              </a:ln>
+              <a:solidFill>
+                <a:schemeClr val="tx1"/>
+              </a:solidFill>
+              <a:effectLst/>
+              <a:latin typeface="Arial" panose="020B0604020202020204" pitchFamily="34" charset="0"/>
+            </a:endParaRPr>
+          </a:p>
+          <a:p>
+            <a:pPr>
+              <a:lnSpc>
+                <a:spcPct val="150000"/>
+              </a:lnSpc>
+              <a:buNone/>
+            </a:pPr>
+            <a:endParaRPr lang="az-Latn-AZ" altLang="en-US" sz="1300">
+              <a:latin typeface="Arial" panose="020B0604020202020204" pitchFamily="34" charset="0"/>
+            </a:endParaRPr>
+          </a:p>
+          <a:p>
+            <a:pPr>
+              <a:lnSpc>
+                <a:spcPct val="150000"/>
+              </a:lnSpc>
+              <a:buNone/>
+            </a:pPr>
+            <a:endParaRPr kumimoji="0" lang="az-Latn-AZ" altLang="en-US" sz="1300" b="0" i="0" u="none" strike="noStrike" cap="none" normalizeH="0" baseline="0">
+              <a:ln>
+                <a:noFill/>
+              </a:ln>
+              <a:solidFill>
+                <a:schemeClr val="tx1"/>
+              </a:solidFill>
+              <a:effectLst/>
+              <a:latin typeface="Arial" panose="020B0604020202020204" pitchFamily="34" charset="0"/>
+            </a:endParaRPr>
+          </a:p>
+          <a:p>
+            <a:pPr>
+              <a:lnSpc>
+                <a:spcPct val="150000"/>
+              </a:lnSpc>
+              <a:buNone/>
+            </a:pPr>
+            <a:endParaRPr lang="az-Latn-AZ" altLang="en-US" sz="1300">
+              <a:latin typeface="Arial" panose="020B0604020202020204" pitchFamily="34" charset="0"/>
+            </a:endParaRPr>
+          </a:p>
+          <a:p>
+            <a:pPr>
+              <a:lnSpc>
+                <a:spcPct val="150000"/>
+              </a:lnSpc>
+              <a:buNone/>
+            </a:pPr>
+            <a:endParaRPr kumimoji="0" lang="az-Latn-AZ" altLang="en-US" sz="1300" b="0" i="0" u="none" strike="noStrike" cap="none" normalizeH="0" baseline="0">
+              <a:ln>
+                <a:noFill/>
+              </a:ln>
+              <a:solidFill>
+                <a:schemeClr val="tx1"/>
+              </a:solidFill>
+              <a:effectLst/>
+              <a:latin typeface="Arial" panose="020B0604020202020204" pitchFamily="34" charset="0"/>
+            </a:endParaRPr>
+          </a:p>
+          <a:p>
+            <a:pPr>
+              <a:lnSpc>
+                <a:spcPct val="150000"/>
+              </a:lnSpc>
+              <a:buNone/>
+            </a:pPr>
+            <a:endParaRPr lang="az-Latn-AZ" altLang="en-US" sz="1300">
+              <a:latin typeface="Arial" panose="020B0604020202020204" pitchFamily="34" charset="0"/>
+            </a:endParaRPr>
+          </a:p>
+          <a:p>
+            <a:pPr>
+              <a:lnSpc>
+                <a:spcPct val="150000"/>
+              </a:lnSpc>
+              <a:buNone/>
+            </a:pPr>
+            <a:r>
+              <a:rPr kumimoji="0" lang="az-Latn-AZ" altLang="en-US" sz="1300" b="1" i="0" u="none" strike="noStrike" cap="none" normalizeH="0" baseline="0">
+                <a:ln>
+                  <a:noFill/>
+                </a:ln>
+                <a:solidFill>
+                  <a:schemeClr val="tx1"/>
+                </a:solidFill>
+                <a:effectLst/>
+                <a:latin typeface="Arial" panose="020B0604020202020204" pitchFamily="34" charset="0"/>
+              </a:rPr>
+              <a:t>Banner</a:t>
+            </a:r>
+            <a:r>
+              <a:rPr kumimoji="0" lang="az-Latn-AZ" altLang="en-US" sz="1300" b="0" i="0" u="none" strike="noStrike" cap="none" normalizeH="0" baseline="0">
+                <a:ln>
+                  <a:noFill/>
+                </a:ln>
+                <a:solidFill>
+                  <a:schemeClr val="tx1"/>
+                </a:solidFill>
+                <a:effectLst/>
+                <a:latin typeface="Arial" panose="020B0604020202020204" pitchFamily="34" charset="0"/>
+              </a:rPr>
+              <a:t> -dən başqa digər məlumatlar </a:t>
+            </a:r>
+            <a:r>
+              <a:rPr kumimoji="0" lang="az-Latn-AZ" altLang="en-US" sz="1300" b="1" i="0" u="none" strike="noStrike" cap="none" normalizeH="0" baseline="0">
+                <a:ln>
+                  <a:noFill/>
+                </a:ln>
+                <a:solidFill>
+                  <a:schemeClr val="tx1"/>
+                </a:solidFill>
+                <a:effectLst/>
+                <a:latin typeface="Arial" panose="020B0604020202020204" pitchFamily="34" charset="0"/>
+              </a:rPr>
+              <a:t>Slider</a:t>
+            </a:r>
+            <a:r>
+              <a:rPr kumimoji="0" lang="az-Latn-AZ" altLang="en-US" sz="1300" b="0" i="0" u="none" strike="noStrike" cap="none" normalizeH="0" baseline="0">
+                <a:ln>
+                  <a:noFill/>
+                </a:ln>
+                <a:solidFill>
+                  <a:schemeClr val="tx1"/>
+                </a:solidFill>
+                <a:effectLst/>
+                <a:latin typeface="Arial" panose="020B0604020202020204" pitchFamily="34" charset="0"/>
+              </a:rPr>
+              <a:t> cədvəlinə yazıldı.</a:t>
+            </a:r>
+            <a:endParaRPr kumimoji="0" lang="en-US" altLang="en-US" sz="1300" b="0" i="0" u="none" strike="noStrike" cap="none" normalizeH="0" baseline="0">
+              <a:ln>
+                <a:noFill/>
+              </a:ln>
+              <a:solidFill>
+                <a:schemeClr val="tx1"/>
+              </a:solidFill>
+              <a:effectLst/>
+              <a:latin typeface="Arial" panose="020B0604020202020204" pitchFamily="34" charset="0"/>
+            </a:endParaRPr>
+          </a:p>
+        </p:txBody>
+      </p:sp>
+      <p:pic>
+        <p:nvPicPr>
+          <p:cNvPr id="4" name="Picture 3">
+            <a:extLst>
+              <a:ext uri="{FF2B5EF4-FFF2-40B4-BE49-F238E27FC236}">
+                <a16:creationId xmlns:a16="http://schemas.microsoft.com/office/drawing/2014/main" id="{CA9EC53A-6492-6376-3356-D122C0127ED2}"/>
+              </a:ext>
+            </a:extLst>
+          </p:cNvPr>
+          <p:cNvPicPr>
+            <a:picLocks noChangeAspect="1"/>
+          </p:cNvPicPr>
+          <p:nvPr/>
+        </p:nvPicPr>
+        <p:blipFill>
+          <a:blip r:embed="rId2"/>
+          <a:stretch>
+            <a:fillRect/>
+          </a:stretch>
+        </p:blipFill>
+        <p:spPr>
+          <a:xfrm>
+            <a:off x="0" y="580271"/>
+            <a:ext cx="12192000" cy="2001293"/>
+          </a:xfrm>
+          <a:prstGeom prst="rect">
+            <a:avLst/>
+          </a:prstGeom>
+          <a:ln w="38100" cap="sq">
+            <a:solidFill>
+              <a:srgbClr val="000000"/>
+            </a:solidFill>
+            <a:prstDash val="solid"/>
+            <a:miter lim="800000"/>
+          </a:ln>
+          <a:effectLst>
+            <a:outerShdw blurRad="50800" dist="38100" dir="2700000" algn="tl" rotWithShape="0">
+              <a:srgbClr val="000000">
+                <a:alpha val="43000"/>
+              </a:srgbClr>
+            </a:outerShdw>
+          </a:effectLst>
+        </p:spPr>
+      </p:pic>
+      <p:pic>
+        <p:nvPicPr>
+          <p:cNvPr id="6" name="Picture 5">
+            <a:extLst>
+              <a:ext uri="{FF2B5EF4-FFF2-40B4-BE49-F238E27FC236}">
+                <a16:creationId xmlns:a16="http://schemas.microsoft.com/office/drawing/2014/main" id="{2281E5E0-C6E1-6E7E-C8C2-A5FB43F4A06D}"/>
+              </a:ext>
+            </a:extLst>
+          </p:cNvPr>
+          <p:cNvPicPr>
+            <a:picLocks noChangeAspect="1"/>
+          </p:cNvPicPr>
+          <p:nvPr/>
+        </p:nvPicPr>
+        <p:blipFill>
+          <a:blip r:embed="rId3"/>
+          <a:stretch>
+            <a:fillRect/>
+          </a:stretch>
+        </p:blipFill>
+        <p:spPr>
+          <a:xfrm>
+            <a:off x="-1" y="3754582"/>
+            <a:ext cx="12192000" cy="3103418"/>
+          </a:xfrm>
+          <a:prstGeom prst="rect">
+            <a:avLst/>
+          </a:prstGeom>
+          <a:ln w="38100" cap="sq">
+            <a:solidFill>
+              <a:srgbClr val="000000"/>
+            </a:solidFill>
+            <a:prstDash val="solid"/>
+            <a:miter lim="800000"/>
+          </a:ln>
+          <a:effectLst>
+            <a:outerShdw blurRad="50800" dist="38100" dir="2700000" algn="tl" rotWithShape="0">
+              <a:srgbClr val="000000">
+                <a:alpha val="43000"/>
+              </a:srgbClr>
+            </a:outerShdw>
+          </a:effectLst>
+        </p:spPr>
+      </p:pic>
+    </p:spTree>
+    <p:extLst>
+      <p:ext uri="{BB962C8B-B14F-4D97-AF65-F5344CB8AC3E}">
+        <p14:creationId xmlns:p14="http://schemas.microsoft.com/office/powerpoint/2010/main" val="149398420"/>
+      </p:ext>
+    </p:extLst>
+  </p:cSld>
+  <p:clrMapOvr>
+    <a:masterClrMapping/>
+  </p:clrMapOvr>
+</p:sld>
+</file>
+
+<file path=ppt/slides/slide7.xml><?xml version="1.0" encoding="utf-8"?>
 <p:sld xmlns:a="http://schemas.openxmlformats.org/drawingml/2006/main" xmlns:r="http://schemas.openxmlformats.org/officeDocument/2006/relationships" xmlns:p="http://schemas.openxmlformats.org/presentationml/2006/main">
   <p:cSld>
     <p:spTree>
@@ -3541,6 +4522,188 @@
               <a:buNone/>
             </a:pPr>
             <a:r>
+              <a:rPr lang="en-US" altLang="en-US" sz="1300" b="1">
+                <a:latin typeface="Arial" panose="020B0604020202020204" pitchFamily="34" charset="0"/>
+              </a:rPr>
+              <a:t>Create</a:t>
+            </a:r>
+            <a:r>
+              <a:rPr lang="en-US" altLang="en-US" sz="1300">
+                <a:latin typeface="Arial" panose="020B0604020202020204" pitchFamily="34" charset="0"/>
+              </a:rPr>
+              <a:t> d</a:t>
+            </a:r>
+            <a:r>
+              <a:rPr lang="az-Latn-AZ" altLang="en-US" sz="1300">
+                <a:latin typeface="Arial" panose="020B0604020202020204" pitchFamily="34" charset="0"/>
+              </a:rPr>
+              <a:t>üyməsini basdıqda </a:t>
+            </a:r>
+            <a:r>
+              <a:rPr lang="az-Latn-AZ" altLang="en-US" sz="1300" b="1">
+                <a:latin typeface="Arial" panose="020B0604020202020204" pitchFamily="34" charset="0"/>
+              </a:rPr>
+              <a:t>input</a:t>
+            </a:r>
+            <a:r>
+              <a:rPr lang="az-Latn-AZ" altLang="en-US" sz="1300">
+                <a:latin typeface="Arial" panose="020B0604020202020204" pitchFamily="34" charset="0"/>
+              </a:rPr>
+              <a:t> sahələrinə yazılan </a:t>
+            </a:r>
+            <a:r>
+              <a:rPr lang="az-Latn-AZ" altLang="en-US" sz="1300" b="1">
+                <a:latin typeface="Arial" panose="020B0604020202020204" pitchFamily="34" charset="0"/>
+              </a:rPr>
+              <a:t>dəyərlər</a:t>
+            </a:r>
+            <a:r>
+              <a:rPr lang="az-Latn-AZ" altLang="en-US" sz="1300">
+                <a:latin typeface="Arial" panose="020B0604020202020204" pitchFamily="34" charset="0"/>
+              </a:rPr>
+              <a:t> itməsin deyə,  ` </a:t>
+            </a:r>
+            <a:r>
+              <a:rPr lang="az-Latn-AZ" altLang="en-US" sz="1300" b="1">
+                <a:latin typeface="Arial" panose="020B0604020202020204" pitchFamily="34" charset="0"/>
+              </a:rPr>
+              <a:t>value="{{ </a:t>
+            </a:r>
+            <a:r>
+              <a:rPr lang="az-Latn-AZ" altLang="en-US" sz="1300" b="1">
+                <a:solidFill>
+                  <a:srgbClr val="FF0000"/>
+                </a:solidFill>
+                <a:latin typeface="Arial" panose="020B0604020202020204" pitchFamily="34" charset="0"/>
+              </a:rPr>
+              <a:t>old('') </a:t>
+            </a:r>
+            <a:r>
+              <a:rPr lang="az-Latn-AZ" altLang="en-US" sz="1300" b="1">
+                <a:latin typeface="Arial" panose="020B0604020202020204" pitchFamily="34" charset="0"/>
+              </a:rPr>
+              <a:t>}}" </a:t>
+            </a:r>
+            <a:r>
+              <a:rPr lang="az-Latn-AZ" altLang="en-US" sz="1300">
+                <a:latin typeface="Arial" panose="020B0604020202020204" pitchFamily="34" charset="0"/>
+              </a:rPr>
+              <a:t>`  adında atribut əlavə edirik.</a:t>
+            </a:r>
+            <a:endParaRPr kumimoji="0" lang="en-US" altLang="en-US" sz="1300" b="0" i="0" u="none" strike="noStrike" cap="none" normalizeH="0" baseline="0">
+              <a:ln>
+                <a:noFill/>
+              </a:ln>
+              <a:solidFill>
+                <a:schemeClr val="tx1"/>
+              </a:solidFill>
+              <a:effectLst/>
+              <a:latin typeface="Arial" panose="020B0604020202020204" pitchFamily="34" charset="0"/>
+            </a:endParaRPr>
+          </a:p>
+        </p:txBody>
+      </p:sp>
+      <p:pic>
+        <p:nvPicPr>
+          <p:cNvPr id="4" name="Picture 3">
+            <a:extLst>
+              <a:ext uri="{FF2B5EF4-FFF2-40B4-BE49-F238E27FC236}">
+                <a16:creationId xmlns:a16="http://schemas.microsoft.com/office/drawing/2014/main" id="{8A4717F3-B096-E3D6-D79D-391BCF0CC861}"/>
+              </a:ext>
+            </a:extLst>
+          </p:cNvPr>
+          <p:cNvPicPr>
+            <a:picLocks noChangeAspect="1"/>
+          </p:cNvPicPr>
+          <p:nvPr/>
+        </p:nvPicPr>
+        <p:blipFill>
+          <a:blip r:embed="rId2"/>
+          <a:stretch>
+            <a:fillRect/>
+          </a:stretch>
+        </p:blipFill>
+        <p:spPr>
+          <a:xfrm>
+            <a:off x="3260436" y="821370"/>
+            <a:ext cx="8931564" cy="6036630"/>
+          </a:xfrm>
+          <a:prstGeom prst="rect">
+            <a:avLst/>
+          </a:prstGeom>
+        </p:spPr>
+      </p:pic>
+    </p:spTree>
+    <p:extLst>
+      <p:ext uri="{BB962C8B-B14F-4D97-AF65-F5344CB8AC3E}">
+        <p14:creationId xmlns:p14="http://schemas.microsoft.com/office/powerpoint/2010/main" val="3095838342"/>
+      </p:ext>
+    </p:extLst>
+  </p:cSld>
+  <p:clrMapOvr>
+    <a:masterClrMapping/>
+  </p:clrMapOvr>
+</p:sld>
+</file>
+
+<file path=ppt/slides/slide8.xml><?xml version="1.0" encoding="utf-8"?>
+<p:sld xmlns:a="http://schemas.openxmlformats.org/drawingml/2006/main" xmlns:r="http://schemas.openxmlformats.org/officeDocument/2006/relationships" xmlns:p="http://schemas.openxmlformats.org/presentationml/2006/main">
+  <p:cSld>
+    <p:spTree>
+      <p:nvGrpSpPr>
+        <p:cNvPr id="1" name="">
+          <a:extLst>
+            <a:ext uri="{FF2B5EF4-FFF2-40B4-BE49-F238E27FC236}">
+              <a16:creationId xmlns:a16="http://schemas.microsoft.com/office/drawing/2014/main" id="{6C5336ED-8AF0-6F6A-DA48-39F5D84907BB}"/>
+            </a:ext>
+          </a:extLst>
+        </p:cNvPr>
+        <p:cNvGrpSpPr/>
+        <p:nvPr/>
+      </p:nvGrpSpPr>
+      <p:grpSpPr>
+        <a:xfrm>
+          <a:off x="0" y="0"/>
+          <a:ext cx="0" cy="0"/>
+          <a:chOff x="0" y="0"/>
+          <a:chExt cx="0" cy="0"/>
+        </a:xfrm>
+      </p:grpSpPr>
+      <p:sp>
+        <p:nvSpPr>
+          <p:cNvPr id="3" name="TextBox 2">
+            <a:extLst>
+              <a:ext uri="{FF2B5EF4-FFF2-40B4-BE49-F238E27FC236}">
+                <a16:creationId xmlns:a16="http://schemas.microsoft.com/office/drawing/2014/main" id="{AD2689A7-54C4-74BE-EA6B-48CB092DF72E}"/>
+              </a:ext>
+            </a:extLst>
+          </p:cNvPr>
+          <p:cNvSpPr txBox="1"/>
+          <p:nvPr/>
+        </p:nvSpPr>
+        <p:spPr>
+          <a:xfrm>
+            <a:off x="217714" y="255046"/>
+            <a:ext cx="11756571" cy="355354"/>
+          </a:xfrm>
+          <a:prstGeom prst="rect">
+            <a:avLst/>
+          </a:prstGeom>
+          <a:noFill/>
+        </p:spPr>
+        <p:txBody>
+          <a:bodyPr wrap="square">
+            <a:spAutoFit/>
+          </a:bodyPr>
+          <a:lstStyle/>
+          <a:p>
+            <a:pPr>
+              <a:lnSpc>
+                <a:spcPct val="150000"/>
+              </a:lnSpc>
+              <a:buNone/>
+            </a:pPr>
+            <a:r>
               <a:rPr kumimoji="0" lang="en-US" altLang="en-US" sz="1300" b="0" i="0" u="none" strike="noStrike" cap="none" normalizeH="0" baseline="0">
                 <a:ln>
                   <a:noFill/>
@@ -3559,7 +4722,93 @@
     </p:spTree>
     <p:extLst>
       <p:ext uri="{BB962C8B-B14F-4D97-AF65-F5344CB8AC3E}">
-        <p14:creationId xmlns:p14="http://schemas.microsoft.com/office/powerpoint/2010/main" val="3095838342"/>
+        <p14:creationId xmlns:p14="http://schemas.microsoft.com/office/powerpoint/2010/main" val="1882718817"/>
+      </p:ext>
+    </p:extLst>
+  </p:cSld>
+  <p:clrMapOvr>
+    <a:masterClrMapping/>
+  </p:clrMapOvr>
+</p:sld>
+</file>
+
+<file path=ppt/slides/slide9.xml><?xml version="1.0" encoding="utf-8"?>
+<p:sld xmlns:a="http://schemas.openxmlformats.org/drawingml/2006/main" xmlns:r="http://schemas.openxmlformats.org/officeDocument/2006/relationships" xmlns:p="http://schemas.openxmlformats.org/presentationml/2006/main">
+  <p:cSld>
+    <p:spTree>
+      <p:nvGrpSpPr>
+        <p:cNvPr id="1" name="">
+          <a:extLst>
+            <a:ext uri="{FF2B5EF4-FFF2-40B4-BE49-F238E27FC236}">
+              <a16:creationId xmlns:a16="http://schemas.microsoft.com/office/drawing/2014/main" id="{5F94AC5F-8CAE-4D49-6352-51B0A7A8857B}"/>
+            </a:ext>
+          </a:extLst>
+        </p:cNvPr>
+        <p:cNvGrpSpPr/>
+        <p:nvPr/>
+      </p:nvGrpSpPr>
+      <p:grpSpPr>
+        <a:xfrm>
+          <a:off x="0" y="0"/>
+          <a:ext cx="0" cy="0"/>
+          <a:chOff x="0" y="0"/>
+          <a:chExt cx="0" cy="0"/>
+        </a:xfrm>
+      </p:grpSpPr>
+      <p:sp>
+        <p:nvSpPr>
+          <p:cNvPr id="3" name="TextBox 2">
+            <a:extLst>
+              <a:ext uri="{FF2B5EF4-FFF2-40B4-BE49-F238E27FC236}">
+                <a16:creationId xmlns:a16="http://schemas.microsoft.com/office/drawing/2014/main" id="{1E388DB0-7830-1A91-26BB-66A007009B7A}"/>
+              </a:ext>
+            </a:extLst>
+          </p:cNvPr>
+          <p:cNvSpPr txBox="1"/>
+          <p:nvPr/>
+        </p:nvSpPr>
+        <p:spPr>
+          <a:xfrm>
+            <a:off x="217714" y="255046"/>
+            <a:ext cx="11756571" cy="355354"/>
+          </a:xfrm>
+          <a:prstGeom prst="rect">
+            <a:avLst/>
+          </a:prstGeom>
+          <a:noFill/>
+        </p:spPr>
+        <p:txBody>
+          <a:bodyPr wrap="square">
+            <a:spAutoFit/>
+          </a:bodyPr>
+          <a:lstStyle/>
+          <a:p>
+            <a:pPr>
+              <a:lnSpc>
+                <a:spcPct val="150000"/>
+              </a:lnSpc>
+              <a:buNone/>
+            </a:pPr>
+            <a:r>
+              <a:rPr kumimoji="0" lang="en-US" altLang="en-US" sz="1300" b="0" i="0" u="none" strike="noStrike" cap="none" normalizeH="0" baseline="0">
+                <a:ln>
+                  <a:noFill/>
+                </a:ln>
+                <a:solidFill>
+                  <a:schemeClr val="tx1"/>
+                </a:solidFill>
+                <a:effectLst/>
+                <a:latin typeface="Arial" panose="020B0604020202020204" pitchFamily="34" charset="0"/>
+              </a:rPr>
+              <a:t>.</a:t>
+            </a:r>
+          </a:p>
+        </p:txBody>
+      </p:sp>
+    </p:spTree>
+    <p:extLst>
+      <p:ext uri="{BB962C8B-B14F-4D97-AF65-F5344CB8AC3E}">
+        <p14:creationId xmlns:p14="http://schemas.microsoft.com/office/powerpoint/2010/main" val="356738660"/>
       </p:ext>
     </p:extLst>
   </p:cSld>

</xml_diff>